<commit_message>
Refactor UI for Customer Churn Predictor app with updated styling, improved layout, and added visualizations for enhanced user experience
</commit_message>
<xml_diff>
--- a/CustomerChurnPrediction_Presentation.pptx
+++ b/CustomerChurnPrediction_Presentation.pptx
@@ -5,17 +5,17 @@
     <p:sldMasterId id="2147483648" r:id="rId1"/>
   </p:sldMasterIdLst>
   <p:sldIdLst>
-    <p:sldId id="256" r:id="rId7"/>
-    <p:sldId id="257" r:id="rId8"/>
-    <p:sldId id="258" r:id="rId9"/>
-    <p:sldId id="259" r:id="rId10"/>
-    <p:sldId id="260" r:id="rId11"/>
-    <p:sldId id="261" r:id="rId12"/>
-    <p:sldId id="262" r:id="rId13"/>
-    <p:sldId id="263" r:id="rId14"/>
-    <p:sldId id="264" r:id="rId15"/>
+    <p:sldId id="256" r:id="rId2"/>
+    <p:sldId id="257" r:id="rId3"/>
+    <p:sldId id="258" r:id="rId4"/>
+    <p:sldId id="259" r:id="rId5"/>
+    <p:sldId id="260" r:id="rId6"/>
+    <p:sldId id="261" r:id="rId7"/>
+    <p:sldId id="262" r:id="rId8"/>
+    <p:sldId id="263" r:id="rId9"/>
+    <p:sldId id="264" r:id="rId10"/>
   </p:sldIdLst>
-  <p:sldSz cx="12188952" cy="6858000" type="screen4x3"/>
+  <p:sldSz cx="12188825" cy="6858000"/>
   <p:notesSz cx="6858000" cy="9144000"/>
   <p:defaultTextStyle>
     <a:defPPr>
@@ -112,7 +112,100 @@
       </a:defRPr>
     </a:lvl9pPr>
   </p:defaultTextStyle>
+  <p:extLst>
+    <p:ext uri="{EFAFB233-063F-42B5-8137-9DF3F51BA10A}">
+      <p15:sldGuideLst xmlns:p15="http://schemas.microsoft.com/office/powerpoint/2012/main">
+        <p15:guide id="1" orient="horz" pos="2160">
+          <p15:clr>
+            <a:srgbClr val="A4A3A4"/>
+          </p15:clr>
+        </p15:guide>
+        <p15:guide id="2" pos="2880">
+          <p15:clr>
+            <a:srgbClr val="A4A3A4"/>
+          </p15:clr>
+        </p15:guide>
+      </p15:sldGuideLst>
+    </p:ext>
+  </p:extLst>
 </p:presentation>
+</file>
+
+<file path=ppt/revisionInfo.xml><?xml version="1.0" encoding="utf-8"?>
+<p1510:revInfo xmlns:a="http://schemas.openxmlformats.org/drawingml/2006/main" xmlns:r="http://schemas.openxmlformats.org/officeDocument/2006/relationships" xmlns:p1510="http://schemas.microsoft.com/office/powerpoint/2015/10/main">
+  <p1510:revLst>
+    <p1510:client id="{FE69147F-8F51-4716-87B8-57775AE2AF05}" v="2" dt="2026-04-21T09:16:41.521"/>
+  </p1510:revLst>
+</p1510:revInfo>
+</file>
+
+<file path=ppt/changesInfos/changesInfo1.xml><?xml version="1.0" encoding="utf-8"?>
+<pc:chgInfo xmlns:a="http://schemas.openxmlformats.org/drawingml/2006/main" xmlns:r="http://schemas.openxmlformats.org/officeDocument/2006/relationships" xmlns:ac="http://schemas.microsoft.com/office/drawing/2013/main/command" xmlns:pc="http://schemas.microsoft.com/office/powerpoint/2013/main/command">
+  <pc:docChgLst>
+    <pc:chgData name="dev.solanki.works@gmail.com" userId="52c76854b4a9ec1a" providerId="LiveId" clId="{A0204B83-AD7A-4025-9810-B3DCB1D84747}"/>
+    <pc:docChg chg="modSld">
+      <pc:chgData name="dev.solanki.works@gmail.com" userId="52c76854b4a9ec1a" providerId="LiveId" clId="{A0204B83-AD7A-4025-9810-B3DCB1D84747}" dt="2026-04-21T09:17:09.445" v="104" actId="20577"/>
+      <pc:docMkLst>
+        <pc:docMk/>
+      </pc:docMkLst>
+      <pc:sldChg chg="modSp mod">
+        <pc:chgData name="dev.solanki.works@gmail.com" userId="52c76854b4a9ec1a" providerId="LiveId" clId="{A0204B83-AD7A-4025-9810-B3DCB1D84747}" dt="2026-04-21T09:17:09.445" v="104" actId="20577"/>
+        <pc:sldMkLst>
+          <pc:docMk/>
+          <pc:sldMk cId="0" sldId="256"/>
+        </pc:sldMkLst>
+        <pc:spChg chg="mod">
+          <ac:chgData name="dev.solanki.works@gmail.com" userId="52c76854b4a9ec1a" providerId="LiveId" clId="{A0204B83-AD7A-4025-9810-B3DCB1D84747}" dt="2026-04-21T09:15:52.521" v="30" actId="20577"/>
+          <ac:spMkLst>
+            <pc:docMk/>
+            <pc:sldMk cId="0" sldId="256"/>
+            <ac:spMk id="4" creationId="{00000000-0000-0000-0000-000000000000}"/>
+          </ac:spMkLst>
+        </pc:spChg>
+        <pc:spChg chg="mod">
+          <ac:chgData name="dev.solanki.works@gmail.com" userId="52c76854b4a9ec1a" providerId="LiveId" clId="{A0204B83-AD7A-4025-9810-B3DCB1D84747}" dt="2026-04-21T09:16:02.499" v="42" actId="20577"/>
+          <ac:spMkLst>
+            <pc:docMk/>
+            <pc:sldMk cId="0" sldId="256"/>
+            <ac:spMk id="5" creationId="{00000000-0000-0000-0000-000000000000}"/>
+          </ac:spMkLst>
+        </pc:spChg>
+        <pc:spChg chg="mod">
+          <ac:chgData name="dev.solanki.works@gmail.com" userId="52c76854b4a9ec1a" providerId="LiveId" clId="{A0204B83-AD7A-4025-9810-B3DCB1D84747}" dt="2026-04-21T09:16:14.797" v="57" actId="20577"/>
+          <ac:spMkLst>
+            <pc:docMk/>
+            <pc:sldMk cId="0" sldId="256"/>
+            <ac:spMk id="13" creationId="{00000000-0000-0000-0000-000000000000}"/>
+          </ac:spMkLst>
+        </pc:spChg>
+        <pc:spChg chg="mod">
+          <ac:chgData name="dev.solanki.works@gmail.com" userId="52c76854b4a9ec1a" providerId="LiveId" clId="{A0204B83-AD7A-4025-9810-B3DCB1D84747}" dt="2026-04-21T09:16:23.506" v="72" actId="20577"/>
+          <ac:spMkLst>
+            <pc:docMk/>
+            <pc:sldMk cId="0" sldId="256"/>
+            <ac:spMk id="17" creationId="{00000000-0000-0000-0000-000000000000}"/>
+          </ac:spMkLst>
+        </pc:spChg>
+        <pc:spChg chg="mod">
+          <ac:chgData name="dev.solanki.works@gmail.com" userId="52c76854b4a9ec1a" providerId="LiveId" clId="{A0204B83-AD7A-4025-9810-B3DCB1D84747}" dt="2026-04-21T09:16:51.858" v="91" actId="20577"/>
+          <ac:spMkLst>
+            <pc:docMk/>
+            <pc:sldMk cId="0" sldId="256"/>
+            <ac:spMk id="21" creationId="{00000000-0000-0000-0000-000000000000}"/>
+          </ac:spMkLst>
+        </pc:spChg>
+        <pc:spChg chg="mod">
+          <ac:chgData name="dev.solanki.works@gmail.com" userId="52c76854b4a9ec1a" providerId="LiveId" clId="{A0204B83-AD7A-4025-9810-B3DCB1D84747}" dt="2026-04-21T09:17:09.445" v="104" actId="20577"/>
+          <ac:spMkLst>
+            <pc:docMk/>
+            <pc:sldMk cId="0" sldId="256"/>
+            <ac:spMk id="25" creationId="{00000000-0000-0000-0000-000000000000}"/>
+          </ac:spMkLst>
+        </pc:spChg>
+      </pc:sldChg>
+    </pc:docChg>
+  </pc:docChgLst>
+</pc:chgInfo>
 </file>
 
 <file path=ppt/slideLayouts/slideLayout1.xml><?xml version="1.0" encoding="utf-8"?>
@@ -153,10 +246,9 @@
           <a:lstStyle/>
           <a:p>
             <a:r>
-              <a:rPr lang="en-US" smtClean="0"/>
+              <a:rPr lang="en-US"/>
               <a:t>Click to edit Master title style</a:t>
             </a:r>
-            <a:endParaRPr lang="en-US"/>
           </a:p>
         </p:txBody>
       </p:sp>
@@ -272,10 +364,9 @@
           </a:lstStyle>
           <a:p>
             <a:r>
-              <a:rPr lang="en-US" smtClean="0"/>
+              <a:rPr lang="en-US"/>
               <a:t>Click to edit Master subtitle style</a:t>
             </a:r>
-            <a:endParaRPr lang="en-US"/>
           </a:p>
         </p:txBody>
       </p:sp>
@@ -296,7 +387,7 @@
           <a:p>
             <a:fld id="{5BCAD085-E8A6-8845-BD4E-CB4CCA059FC4}" type="datetimeFigureOut">
               <a:rPr lang="en-US" smtClean="0"/>
-              <a:t>1/27/13</a:t>
+              <a:t>4/21/2026</a:t>
             </a:fld>
             <a:endParaRPr lang="en-US"/>
           </a:p>
@@ -390,10 +481,9 @@
           <a:lstStyle/>
           <a:p>
             <a:r>
-              <a:rPr lang="en-US" smtClean="0"/>
+              <a:rPr lang="en-US"/>
               <a:t>Click to edit Master title style</a:t>
             </a:r>
-            <a:endParaRPr lang="en-US"/>
           </a:p>
         </p:txBody>
       </p:sp>
@@ -414,38 +504,37 @@
           <a:p>
             <a:pPr lvl="0"/>
             <a:r>
-              <a:rPr lang="en-US" smtClean="0"/>
+              <a:rPr lang="en-US"/>
               <a:t>Click to edit Master text styles</a:t>
             </a:r>
           </a:p>
           <a:p>
             <a:pPr lvl="1"/>
             <a:r>
-              <a:rPr lang="en-US" smtClean="0"/>
+              <a:rPr lang="en-US"/>
               <a:t>Second level</a:t>
             </a:r>
           </a:p>
           <a:p>
             <a:pPr lvl="2"/>
             <a:r>
-              <a:rPr lang="en-US" smtClean="0"/>
+              <a:rPr lang="en-US"/>
               <a:t>Third level</a:t>
             </a:r>
           </a:p>
           <a:p>
             <a:pPr lvl="3"/>
             <a:r>
-              <a:rPr lang="en-US" smtClean="0"/>
+              <a:rPr lang="en-US"/>
               <a:t>Fourth level</a:t>
             </a:r>
           </a:p>
           <a:p>
             <a:pPr lvl="4"/>
             <a:r>
-              <a:rPr lang="en-US" smtClean="0"/>
+              <a:rPr lang="en-US"/>
               <a:t>Fifth level</a:t>
             </a:r>
-            <a:endParaRPr lang="en-US"/>
           </a:p>
         </p:txBody>
       </p:sp>
@@ -466,7 +555,7 @@
           <a:p>
             <a:fld id="{5BCAD085-E8A6-8845-BD4E-CB4CCA059FC4}" type="datetimeFigureOut">
               <a:rPr lang="en-US" smtClean="0"/>
-              <a:t>1/27/13</a:t>
+              <a:t>4/21/2026</a:t>
             </a:fld>
             <a:endParaRPr lang="en-US"/>
           </a:p>
@@ -565,10 +654,9 @@
           <a:lstStyle/>
           <a:p>
             <a:r>
-              <a:rPr lang="en-US" smtClean="0"/>
+              <a:rPr lang="en-US"/>
               <a:t>Click to edit Master title style</a:t>
             </a:r>
-            <a:endParaRPr lang="en-US"/>
           </a:p>
         </p:txBody>
       </p:sp>
@@ -594,38 +682,37 @@
           <a:p>
             <a:pPr lvl="0"/>
             <a:r>
-              <a:rPr lang="en-US" smtClean="0"/>
+              <a:rPr lang="en-US"/>
               <a:t>Click to edit Master text styles</a:t>
             </a:r>
           </a:p>
           <a:p>
             <a:pPr lvl="1"/>
             <a:r>
-              <a:rPr lang="en-US" smtClean="0"/>
+              <a:rPr lang="en-US"/>
               <a:t>Second level</a:t>
             </a:r>
           </a:p>
           <a:p>
             <a:pPr lvl="2"/>
             <a:r>
-              <a:rPr lang="en-US" smtClean="0"/>
+              <a:rPr lang="en-US"/>
               <a:t>Third level</a:t>
             </a:r>
           </a:p>
           <a:p>
             <a:pPr lvl="3"/>
             <a:r>
-              <a:rPr lang="en-US" smtClean="0"/>
+              <a:rPr lang="en-US"/>
               <a:t>Fourth level</a:t>
             </a:r>
           </a:p>
           <a:p>
             <a:pPr lvl="4"/>
             <a:r>
-              <a:rPr lang="en-US" smtClean="0"/>
+              <a:rPr lang="en-US"/>
               <a:t>Fifth level</a:t>
             </a:r>
-            <a:endParaRPr lang="en-US"/>
           </a:p>
         </p:txBody>
       </p:sp>
@@ -646,7 +733,7 @@
           <a:p>
             <a:fld id="{5BCAD085-E8A6-8845-BD4E-CB4CCA059FC4}" type="datetimeFigureOut">
               <a:rPr lang="en-US" smtClean="0"/>
-              <a:t>1/27/13</a:t>
+              <a:t>4/21/2026</a:t>
             </a:fld>
             <a:endParaRPr lang="en-US"/>
           </a:p>
@@ -740,10 +827,9 @@
           <a:lstStyle/>
           <a:p>
             <a:r>
-              <a:rPr lang="en-US" smtClean="0"/>
+              <a:rPr lang="en-US"/>
               <a:t>Click to edit Master title style</a:t>
             </a:r>
-            <a:endParaRPr lang="en-US"/>
           </a:p>
         </p:txBody>
       </p:sp>
@@ -764,38 +850,37 @@
           <a:p>
             <a:pPr lvl="0"/>
             <a:r>
-              <a:rPr lang="en-US" smtClean="0"/>
+              <a:rPr lang="en-US"/>
               <a:t>Click to edit Master text styles</a:t>
             </a:r>
           </a:p>
           <a:p>
             <a:pPr lvl="1"/>
             <a:r>
-              <a:rPr lang="en-US" smtClean="0"/>
+              <a:rPr lang="en-US"/>
               <a:t>Second level</a:t>
             </a:r>
           </a:p>
           <a:p>
             <a:pPr lvl="2"/>
             <a:r>
-              <a:rPr lang="en-US" smtClean="0"/>
+              <a:rPr lang="en-US"/>
               <a:t>Third level</a:t>
             </a:r>
           </a:p>
           <a:p>
             <a:pPr lvl="3"/>
             <a:r>
-              <a:rPr lang="en-US" smtClean="0"/>
+              <a:rPr lang="en-US"/>
               <a:t>Fourth level</a:t>
             </a:r>
           </a:p>
           <a:p>
             <a:pPr lvl="4"/>
             <a:r>
-              <a:rPr lang="en-US" smtClean="0"/>
+              <a:rPr lang="en-US"/>
               <a:t>Fifth level</a:t>
             </a:r>
-            <a:endParaRPr lang="en-US"/>
           </a:p>
         </p:txBody>
       </p:sp>
@@ -816,7 +901,7 @@
           <a:p>
             <a:fld id="{5BCAD085-E8A6-8845-BD4E-CB4CCA059FC4}" type="datetimeFigureOut">
               <a:rPr lang="en-US" smtClean="0"/>
-              <a:t>1/27/13</a:t>
+              <a:t>4/21/2026</a:t>
             </a:fld>
             <a:endParaRPr lang="en-US"/>
           </a:p>
@@ -919,10 +1004,9 @@
           </a:lstStyle>
           <a:p>
             <a:r>
-              <a:rPr lang="en-US" smtClean="0"/>
+              <a:rPr lang="en-US"/>
               <a:t>Click to edit Master title style</a:t>
             </a:r>
-            <a:endParaRPr lang="en-US"/>
           </a:p>
         </p:txBody>
       </p:sp>
@@ -1039,7 +1123,7 @@
           <a:p>
             <a:pPr lvl="0"/>
             <a:r>
-              <a:rPr lang="en-US" smtClean="0"/>
+              <a:rPr lang="en-US"/>
               <a:t>Click to edit Master text styles</a:t>
             </a:r>
           </a:p>
@@ -1062,7 +1146,7 @@
           <a:p>
             <a:fld id="{5BCAD085-E8A6-8845-BD4E-CB4CCA059FC4}" type="datetimeFigureOut">
               <a:rPr lang="en-US" smtClean="0"/>
-              <a:t>1/27/13</a:t>
+              <a:t>4/21/2026</a:t>
             </a:fld>
             <a:endParaRPr lang="en-US"/>
           </a:p>
@@ -1156,10 +1240,9 @@
           <a:lstStyle/>
           <a:p>
             <a:r>
-              <a:rPr lang="en-US" smtClean="0"/>
+              <a:rPr lang="en-US"/>
               <a:t>Click to edit Master title style</a:t>
             </a:r>
-            <a:endParaRPr lang="en-US"/>
           </a:p>
         </p:txBody>
       </p:sp>
@@ -1213,38 +1296,37 @@
           <a:p>
             <a:pPr lvl="0"/>
             <a:r>
-              <a:rPr lang="en-US" smtClean="0"/>
+              <a:rPr lang="en-US"/>
               <a:t>Click to edit Master text styles</a:t>
             </a:r>
           </a:p>
           <a:p>
             <a:pPr lvl="1"/>
             <a:r>
-              <a:rPr lang="en-US" smtClean="0"/>
+              <a:rPr lang="en-US"/>
               <a:t>Second level</a:t>
             </a:r>
           </a:p>
           <a:p>
             <a:pPr lvl="2"/>
             <a:r>
-              <a:rPr lang="en-US" smtClean="0"/>
+              <a:rPr lang="en-US"/>
               <a:t>Third level</a:t>
             </a:r>
           </a:p>
           <a:p>
             <a:pPr lvl="3"/>
             <a:r>
-              <a:rPr lang="en-US" smtClean="0"/>
+              <a:rPr lang="en-US"/>
               <a:t>Fourth level</a:t>
             </a:r>
           </a:p>
           <a:p>
             <a:pPr lvl="4"/>
             <a:r>
-              <a:rPr lang="en-US" smtClean="0"/>
+              <a:rPr lang="en-US"/>
               <a:t>Fifth level</a:t>
             </a:r>
-            <a:endParaRPr lang="en-US"/>
           </a:p>
         </p:txBody>
       </p:sp>
@@ -1298,38 +1380,37 @@
           <a:p>
             <a:pPr lvl="0"/>
             <a:r>
-              <a:rPr lang="en-US" smtClean="0"/>
+              <a:rPr lang="en-US"/>
               <a:t>Click to edit Master text styles</a:t>
             </a:r>
           </a:p>
           <a:p>
             <a:pPr lvl="1"/>
             <a:r>
-              <a:rPr lang="en-US" smtClean="0"/>
+              <a:rPr lang="en-US"/>
               <a:t>Second level</a:t>
             </a:r>
           </a:p>
           <a:p>
             <a:pPr lvl="2"/>
             <a:r>
-              <a:rPr lang="en-US" smtClean="0"/>
+              <a:rPr lang="en-US"/>
               <a:t>Third level</a:t>
             </a:r>
           </a:p>
           <a:p>
             <a:pPr lvl="3"/>
             <a:r>
-              <a:rPr lang="en-US" smtClean="0"/>
+              <a:rPr lang="en-US"/>
               <a:t>Fourth level</a:t>
             </a:r>
           </a:p>
           <a:p>
             <a:pPr lvl="4"/>
             <a:r>
-              <a:rPr lang="en-US" smtClean="0"/>
+              <a:rPr lang="en-US"/>
               <a:t>Fifth level</a:t>
             </a:r>
-            <a:endParaRPr lang="en-US"/>
           </a:p>
         </p:txBody>
       </p:sp>
@@ -1350,7 +1431,7 @@
           <a:p>
             <a:fld id="{5BCAD085-E8A6-8845-BD4E-CB4CCA059FC4}" type="datetimeFigureOut">
               <a:rPr lang="en-US" smtClean="0"/>
-              <a:t>1/27/13</a:t>
+              <a:t>4/21/2026</a:t>
             </a:fld>
             <a:endParaRPr lang="en-US"/>
           </a:p>
@@ -1448,10 +1529,9 @@
           </a:lstStyle>
           <a:p>
             <a:r>
-              <a:rPr lang="en-US" smtClean="0"/>
+              <a:rPr lang="en-US"/>
               <a:t>Click to edit Master title style</a:t>
             </a:r>
-            <a:endParaRPr lang="en-US"/>
           </a:p>
         </p:txBody>
       </p:sp>
@@ -1514,7 +1594,7 @@
           <a:p>
             <a:pPr lvl="0"/>
             <a:r>
-              <a:rPr lang="en-US" smtClean="0"/>
+              <a:rPr lang="en-US"/>
               <a:t>Click to edit Master text styles</a:t>
             </a:r>
           </a:p>
@@ -1570,38 +1650,37 @@
           <a:p>
             <a:pPr lvl="0"/>
             <a:r>
-              <a:rPr lang="en-US" smtClean="0"/>
+              <a:rPr lang="en-US"/>
               <a:t>Click to edit Master text styles</a:t>
             </a:r>
           </a:p>
           <a:p>
             <a:pPr lvl="1"/>
             <a:r>
-              <a:rPr lang="en-US" smtClean="0"/>
+              <a:rPr lang="en-US"/>
               <a:t>Second level</a:t>
             </a:r>
           </a:p>
           <a:p>
             <a:pPr lvl="2"/>
             <a:r>
-              <a:rPr lang="en-US" smtClean="0"/>
+              <a:rPr lang="en-US"/>
               <a:t>Third level</a:t>
             </a:r>
           </a:p>
           <a:p>
             <a:pPr lvl="3"/>
             <a:r>
-              <a:rPr lang="en-US" smtClean="0"/>
+              <a:rPr lang="en-US"/>
               <a:t>Fourth level</a:t>
             </a:r>
           </a:p>
           <a:p>
             <a:pPr lvl="4"/>
             <a:r>
-              <a:rPr lang="en-US" smtClean="0"/>
+              <a:rPr lang="en-US"/>
               <a:t>Fifth level</a:t>
             </a:r>
-            <a:endParaRPr lang="en-US"/>
           </a:p>
         </p:txBody>
       </p:sp>
@@ -1664,7 +1743,7 @@
           <a:p>
             <a:pPr lvl="0"/>
             <a:r>
-              <a:rPr lang="en-US" smtClean="0"/>
+              <a:rPr lang="en-US"/>
               <a:t>Click to edit Master text styles</a:t>
             </a:r>
           </a:p>
@@ -1720,38 +1799,37 @@
           <a:p>
             <a:pPr lvl="0"/>
             <a:r>
-              <a:rPr lang="en-US" smtClean="0"/>
+              <a:rPr lang="en-US"/>
               <a:t>Click to edit Master text styles</a:t>
             </a:r>
           </a:p>
           <a:p>
             <a:pPr lvl="1"/>
             <a:r>
-              <a:rPr lang="en-US" smtClean="0"/>
+              <a:rPr lang="en-US"/>
               <a:t>Second level</a:t>
             </a:r>
           </a:p>
           <a:p>
             <a:pPr lvl="2"/>
             <a:r>
-              <a:rPr lang="en-US" smtClean="0"/>
+              <a:rPr lang="en-US"/>
               <a:t>Third level</a:t>
             </a:r>
           </a:p>
           <a:p>
             <a:pPr lvl="3"/>
             <a:r>
-              <a:rPr lang="en-US" smtClean="0"/>
+              <a:rPr lang="en-US"/>
               <a:t>Fourth level</a:t>
             </a:r>
           </a:p>
           <a:p>
             <a:pPr lvl="4"/>
             <a:r>
-              <a:rPr lang="en-US" smtClean="0"/>
+              <a:rPr lang="en-US"/>
               <a:t>Fifth level</a:t>
             </a:r>
-            <a:endParaRPr lang="en-US"/>
           </a:p>
         </p:txBody>
       </p:sp>
@@ -1772,7 +1850,7 @@
           <a:p>
             <a:fld id="{5BCAD085-E8A6-8845-BD4E-CB4CCA059FC4}" type="datetimeFigureOut">
               <a:rPr lang="en-US" smtClean="0"/>
-              <a:t>1/27/13</a:t>
+              <a:t>4/21/2026</a:t>
             </a:fld>
             <a:endParaRPr lang="en-US"/>
           </a:p>
@@ -1866,10 +1944,9 @@
           <a:lstStyle/>
           <a:p>
             <a:r>
-              <a:rPr lang="en-US" smtClean="0"/>
+              <a:rPr lang="en-US"/>
               <a:t>Click to edit Master title style</a:t>
             </a:r>
-            <a:endParaRPr lang="en-US"/>
           </a:p>
         </p:txBody>
       </p:sp>
@@ -1890,7 +1967,7 @@
           <a:p>
             <a:fld id="{5BCAD085-E8A6-8845-BD4E-CB4CCA059FC4}" type="datetimeFigureOut">
               <a:rPr lang="en-US" smtClean="0"/>
-              <a:t>1/27/13</a:t>
+              <a:t>4/21/2026</a:t>
             </a:fld>
             <a:endParaRPr lang="en-US"/>
           </a:p>
@@ -1985,7 +2062,7 @@
           <a:p>
             <a:fld id="{5BCAD085-E8A6-8845-BD4E-CB4CCA059FC4}" type="datetimeFigureOut">
               <a:rPr lang="en-US" smtClean="0"/>
-              <a:t>1/27/13</a:t>
+              <a:t>4/21/2026</a:t>
             </a:fld>
             <a:endParaRPr lang="en-US"/>
           </a:p>
@@ -2088,10 +2165,9 @@
           </a:lstStyle>
           <a:p>
             <a:r>
-              <a:rPr lang="en-US" smtClean="0"/>
+              <a:rPr lang="en-US"/>
               <a:t>Click to edit Master title style</a:t>
             </a:r>
-            <a:endParaRPr lang="en-US"/>
           </a:p>
         </p:txBody>
       </p:sp>
@@ -2145,38 +2221,37 @@
           <a:p>
             <a:pPr lvl="0"/>
             <a:r>
-              <a:rPr lang="en-US" smtClean="0"/>
+              <a:rPr lang="en-US"/>
               <a:t>Click to edit Master text styles</a:t>
             </a:r>
           </a:p>
           <a:p>
             <a:pPr lvl="1"/>
             <a:r>
-              <a:rPr lang="en-US" smtClean="0"/>
+              <a:rPr lang="en-US"/>
               <a:t>Second level</a:t>
             </a:r>
           </a:p>
           <a:p>
             <a:pPr lvl="2"/>
             <a:r>
-              <a:rPr lang="en-US" smtClean="0"/>
+              <a:rPr lang="en-US"/>
               <a:t>Third level</a:t>
             </a:r>
           </a:p>
           <a:p>
             <a:pPr lvl="3"/>
             <a:r>
-              <a:rPr lang="en-US" smtClean="0"/>
+              <a:rPr lang="en-US"/>
               <a:t>Fourth level</a:t>
             </a:r>
           </a:p>
           <a:p>
             <a:pPr lvl="4"/>
             <a:r>
-              <a:rPr lang="en-US" smtClean="0"/>
+              <a:rPr lang="en-US"/>
               <a:t>Fifth level</a:t>
             </a:r>
-            <a:endParaRPr lang="en-US"/>
           </a:p>
         </p:txBody>
       </p:sp>
@@ -2239,7 +2314,7 @@
           <a:p>
             <a:pPr lvl="0"/>
             <a:r>
-              <a:rPr lang="en-US" smtClean="0"/>
+              <a:rPr lang="en-US"/>
               <a:t>Click to edit Master text styles</a:t>
             </a:r>
           </a:p>
@@ -2262,7 +2337,7 @@
           <a:p>
             <a:fld id="{5BCAD085-E8A6-8845-BD4E-CB4CCA059FC4}" type="datetimeFigureOut">
               <a:rPr lang="en-US" smtClean="0"/>
-              <a:t>1/27/13</a:t>
+              <a:t>4/21/2026</a:t>
             </a:fld>
             <a:endParaRPr lang="en-US"/>
           </a:p>
@@ -2365,10 +2440,9 @@
           </a:lstStyle>
           <a:p>
             <a:r>
-              <a:rPr lang="en-US" smtClean="0"/>
+              <a:rPr lang="en-US"/>
               <a:t>Click to edit Master title style</a:t>
             </a:r>
-            <a:endParaRPr lang="en-US"/>
           </a:p>
         </p:txBody>
       </p:sp>
@@ -2492,7 +2566,7 @@
           <a:p>
             <a:pPr lvl="0"/>
             <a:r>
-              <a:rPr lang="en-US" smtClean="0"/>
+              <a:rPr lang="en-US"/>
               <a:t>Click to edit Master text styles</a:t>
             </a:r>
           </a:p>
@@ -2515,7 +2589,7 @@
           <a:p>
             <a:fld id="{5BCAD085-E8A6-8845-BD4E-CB4CCA059FC4}" type="datetimeFigureOut">
               <a:rPr lang="en-US" smtClean="0"/>
-              <a:t>1/27/13</a:t>
+              <a:t>4/21/2026</a:t>
             </a:fld>
             <a:endParaRPr lang="en-US"/>
           </a:p>
@@ -2624,10 +2698,9 @@
           <a:lstStyle/>
           <a:p>
             <a:r>
-              <a:rPr lang="en-US" smtClean="0"/>
+              <a:rPr lang="en-US"/>
               <a:t>Click to edit Master title style</a:t>
             </a:r>
-            <a:endParaRPr lang="en-US"/>
           </a:p>
         </p:txBody>
       </p:sp>
@@ -2658,38 +2731,37 @@
           <a:p>
             <a:pPr lvl="0"/>
             <a:r>
-              <a:rPr lang="en-US" smtClean="0"/>
+              <a:rPr lang="en-US"/>
               <a:t>Click to edit Master text styles</a:t>
             </a:r>
           </a:p>
           <a:p>
             <a:pPr lvl="1"/>
             <a:r>
-              <a:rPr lang="en-US" smtClean="0"/>
+              <a:rPr lang="en-US"/>
               <a:t>Second level</a:t>
             </a:r>
           </a:p>
           <a:p>
             <a:pPr lvl="2"/>
             <a:r>
-              <a:rPr lang="en-US" smtClean="0"/>
+              <a:rPr lang="en-US"/>
               <a:t>Third level</a:t>
             </a:r>
           </a:p>
           <a:p>
             <a:pPr lvl="3"/>
             <a:r>
-              <a:rPr lang="en-US" smtClean="0"/>
+              <a:rPr lang="en-US"/>
               <a:t>Fourth level</a:t>
             </a:r>
           </a:p>
           <a:p>
             <a:pPr lvl="4"/>
             <a:r>
-              <a:rPr lang="en-US" smtClean="0"/>
+              <a:rPr lang="en-US"/>
               <a:t>Fifth level</a:t>
             </a:r>
-            <a:endParaRPr lang="en-US"/>
           </a:p>
         </p:txBody>
       </p:sp>
@@ -2728,7 +2800,7 @@
           <a:p>
             <a:fld id="{5BCAD085-E8A6-8845-BD4E-CB4CCA059FC4}" type="datetimeFigureOut">
               <a:rPr lang="en-US" smtClean="0"/>
-              <a:t>1/27/13</a:t>
+              <a:t>4/21/2026</a:t>
             </a:fld>
             <a:endParaRPr lang="en-US"/>
           </a:p>
@@ -3087,7 +3159,7 @@
 </file>
 
 <file path=ppt/slides/slide1.xml><?xml version="1.0" encoding="utf-8"?>
-<p:sld xmlns:a="http://schemas.openxmlformats.org/drawingml/2006/main" xmlns:p="http://schemas.openxmlformats.org/presentationml/2006/main" xmlns:r="http://schemas.openxmlformats.org/officeDocument/2006/relationships">
+<p:sld xmlns:a="http://schemas.openxmlformats.org/drawingml/2006/main" xmlns:r="http://schemas.openxmlformats.org/officeDocument/2006/relationships" xmlns:p="http://schemas.openxmlformats.org/presentationml/2006/main">
   <p:cSld>
     <p:bg>
       <p:bgPr>
@@ -3103,7 +3175,14 @@
         <p:cNvGrpSpPr/>
         <p:nvPr/>
       </p:nvGrpSpPr>
-      <p:grpSpPr/>
+      <p:grpSpPr>
+        <a:xfrm>
+          <a:off x="0" y="0"/>
+          <a:ext cx="0" cy="0"/>
+          <a:chOff x="0" y="0"/>
+          <a:chExt cx="0" cy="0"/>
+        </a:xfrm>
+      </p:grpSpPr>
       <p:sp>
         <p:nvSpPr>
           <p:cNvPr id="2" name="Rectangle 1"/>
@@ -3144,6 +3223,7 @@
           <a:lstStyle/>
           <a:p>
             <a:pPr algn="ctr"/>
+            <a:endParaRPr/>
           </a:p>
         </p:txBody>
       </p:sp>
@@ -3187,6 +3267,7 @@
           <a:lstStyle/>
           <a:p>
             <a:pPr algn="ctr"/>
+            <a:endParaRPr/>
           </a:p>
         </p:txBody>
       </p:sp>
@@ -3199,27 +3280,27 @@
         <p:spPr>
           <a:xfrm>
             <a:off x="9646920" y="91440"/>
-            <a:ext cx="2468880" cy="502920"/>
-          </a:xfrm>
-          <a:prstGeom prst="rect">
-            <a:avLst/>
-          </a:prstGeom>
-          <a:noFill/>
-        </p:spPr>
-        <p:txBody>
-          <a:bodyPr wrap="square">
-            <a:spAutoFit/>
-          </a:bodyPr>
-          <a:lstStyle/>
-          <a:p>
-            <a:pPr algn="ctr"/>
-            <a:r>
-              <a:rPr sz="1200" b="0" i="0">
+            <a:ext cx="2468880" cy="276999"/>
+          </a:xfrm>
+          <a:prstGeom prst="rect">
+            <a:avLst/>
+          </a:prstGeom>
+          <a:noFill/>
+        </p:spPr>
+        <p:txBody>
+          <a:bodyPr wrap="square">
+            <a:spAutoFit/>
+          </a:bodyPr>
+          <a:lstStyle/>
+          <a:p>
+            <a:pPr algn="ctr"/>
+            <a:r>
+              <a:rPr lang="en-IN" sz="1200" b="0" i="0" dirty="0">
                 <a:solidFill>
                   <a:srgbClr val="028FBE"/>
                 </a:solidFill>
               </a:rPr>
-              <a:t>B.Tech – Gen AI</a:t>
+              <a:t>GenAI-B </a:t>
             </a:r>
           </a:p>
         </p:txBody>
@@ -3233,28 +3314,44 @@
         <p:spPr>
           <a:xfrm>
             <a:off x="9646920" y="566928"/>
-            <a:ext cx="2468880" cy="457200"/>
-          </a:xfrm>
-          <a:prstGeom prst="rect">
-            <a:avLst/>
-          </a:prstGeom>
-          <a:noFill/>
-        </p:spPr>
-        <p:txBody>
-          <a:bodyPr wrap="square">
-            <a:spAutoFit/>
-          </a:bodyPr>
-          <a:lstStyle/>
-          <a:p>
-            <a:pPr algn="ctr"/>
-            <a:r>
-              <a:rPr sz="1300" b="1" i="0">
+            <a:ext cx="2468880" cy="492443"/>
+          </a:xfrm>
+          <a:prstGeom prst="rect">
+            <a:avLst/>
+          </a:prstGeom>
+          <a:noFill/>
+        </p:spPr>
+        <p:txBody>
+          <a:bodyPr wrap="square">
+            <a:spAutoFit/>
+          </a:bodyPr>
+          <a:lstStyle/>
+          <a:p>
+            <a:pPr algn="ctr"/>
+            <a:r>
+              <a:rPr lang="en-IN" sz="1300" b="1" i="0" dirty="0">
                 <a:solidFill>
                   <a:srgbClr val="FFFFFF"/>
                 </a:solidFill>
               </a:rPr>
-              <a:t>2nd Semester</a:t>
-            </a:r>
+              <a:t>Dev Solanki</a:t>
+            </a:r>
+          </a:p>
+          <a:p>
+            <a:pPr algn="ctr"/>
+            <a:r>
+              <a:rPr lang="en-IN" sz="1300" b="1" dirty="0">
+                <a:solidFill>
+                  <a:srgbClr val="FFFFFF"/>
+                </a:solidFill>
+              </a:rPr>
+              <a:t>KU2507U0215</a:t>
+            </a:r>
+            <a:endParaRPr sz="1300" b="1" i="0" dirty="0">
+              <a:solidFill>
+                <a:srgbClr val="FFFFFF"/>
+              </a:solidFill>
+            </a:endParaRPr>
           </a:p>
         </p:txBody>
       </p:sp>
@@ -3298,6 +3395,7 @@
           <a:lstStyle/>
           <a:p>
             <a:pPr algn="ctr"/>
+            <a:endParaRPr/>
           </a:p>
         </p:txBody>
       </p:sp>
@@ -3443,6 +3541,7 @@
           <a:lstStyle/>
           <a:p>
             <a:pPr algn="ctr"/>
+            <a:endParaRPr/>
           </a:p>
         </p:txBody>
       </p:sp>
@@ -3486,6 +3585,7 @@
           <a:lstStyle/>
           <a:p>
             <a:pPr algn="ctr"/>
+            <a:endParaRPr/>
           </a:p>
         </p:txBody>
       </p:sp>
@@ -3532,7 +3632,7 @@
         <p:spPr>
           <a:xfrm>
             <a:off x="502920" y="4937760"/>
-            <a:ext cx="2468880" cy="411480"/>
+            <a:ext cx="2468880" cy="292388"/>
           </a:xfrm>
           <a:prstGeom prst="rect">
             <a:avLst/>
@@ -3547,13 +3647,18 @@
           <a:p>
             <a:pPr algn="l"/>
             <a:r>
-              <a:rPr sz="1300" b="1" i="0">
+              <a:rPr lang="en-IN" sz="1300" b="1" dirty="0">
                 <a:solidFill>
                   <a:srgbClr val="FFFFFF"/>
                 </a:solidFill>
               </a:rPr>
-              <a:t>[Your Name]</a:t>
-            </a:r>
+              <a:t>Dev Solanki</a:t>
+            </a:r>
+            <a:endParaRPr sz="1300" b="1" i="0" dirty="0">
+              <a:solidFill>
+                <a:srgbClr val="FFFFFF"/>
+              </a:solidFill>
+            </a:endParaRPr>
           </a:p>
         </p:txBody>
       </p:sp>
@@ -3597,6 +3702,7 @@
           <a:lstStyle/>
           <a:p>
             <a:pPr algn="ctr"/>
+            <a:endParaRPr/>
           </a:p>
         </p:txBody>
       </p:sp>
@@ -3640,6 +3746,7 @@
           <a:lstStyle/>
           <a:p>
             <a:pPr algn="ctr"/>
+            <a:endParaRPr/>
           </a:p>
         </p:txBody>
       </p:sp>
@@ -3686,7 +3793,7 @@
         <p:spPr>
           <a:xfrm>
             <a:off x="3429000" y="4937760"/>
-            <a:ext cx="2468880" cy="411480"/>
+            <a:ext cx="2468880" cy="292388"/>
           </a:xfrm>
           <a:prstGeom prst="rect">
             <a:avLst/>
@@ -3701,13 +3808,18 @@
           <a:p>
             <a:pPr algn="l"/>
             <a:r>
-              <a:rPr sz="1300" b="1" i="0">
+              <a:rPr lang="en-IN" sz="1300" b="1" dirty="0">
                 <a:solidFill>
                   <a:srgbClr val="FFFFFF"/>
                 </a:solidFill>
               </a:rPr>
-              <a:t>[Enrollment Number]</a:t>
-            </a:r>
+              <a:t>KU2507U0215</a:t>
+            </a:r>
+            <a:endParaRPr sz="1300" b="1" i="0" dirty="0">
+              <a:solidFill>
+                <a:srgbClr val="FFFFFF"/>
+              </a:solidFill>
+            </a:endParaRPr>
           </a:p>
         </p:txBody>
       </p:sp>
@@ -3751,6 +3863,7 @@
           <a:lstStyle/>
           <a:p>
             <a:pPr algn="ctr"/>
+            <a:endParaRPr/>
           </a:p>
         </p:txBody>
       </p:sp>
@@ -3794,6 +3907,7 @@
           <a:lstStyle/>
           <a:p>
             <a:pPr algn="ctr"/>
+            <a:endParaRPr/>
           </a:p>
         </p:txBody>
       </p:sp>
@@ -3840,7 +3954,7 @@
         <p:spPr>
           <a:xfrm>
             <a:off x="6355080" y="4937760"/>
-            <a:ext cx="2468880" cy="411480"/>
+            <a:ext cx="2468880" cy="292388"/>
           </a:xfrm>
           <a:prstGeom prst="rect">
             <a:avLst/>
@@ -3855,13 +3969,26 @@
           <a:p>
             <a:pPr algn="l"/>
             <a:r>
-              <a:rPr sz="1300" b="1" i="0">
+              <a:rPr lang="en-IN" sz="1300" b="1" i="0" dirty="0">
                 <a:solidFill>
                   <a:srgbClr val="FFFFFF"/>
                 </a:solidFill>
               </a:rPr>
-              <a:t>[Instructor Name]</a:t>
-            </a:r>
+              <a:t>Rishabh </a:t>
+            </a:r>
+            <a:r>
+              <a:rPr lang="en-IN" sz="1300" b="1" i="0" dirty="0" err="1">
+                <a:solidFill>
+                  <a:srgbClr val="FFFFFF"/>
+                </a:solidFill>
+              </a:rPr>
+              <a:t>Bheda</a:t>
+            </a:r>
+            <a:endParaRPr sz="1300" b="1" i="0" dirty="0">
+              <a:solidFill>
+                <a:srgbClr val="FFFFFF"/>
+              </a:solidFill>
+            </a:endParaRPr>
           </a:p>
         </p:txBody>
       </p:sp>
@@ -3905,6 +4032,7 @@
           <a:lstStyle/>
           <a:p>
             <a:pPr algn="ctr"/>
+            <a:endParaRPr/>
           </a:p>
         </p:txBody>
       </p:sp>
@@ -3948,6 +4076,7 @@
           <a:lstStyle/>
           <a:p>
             <a:pPr algn="ctr"/>
+            <a:endParaRPr/>
           </a:p>
         </p:txBody>
       </p:sp>
@@ -3994,7 +4123,7 @@
         <p:spPr>
           <a:xfrm>
             <a:off x="9281160" y="4937760"/>
-            <a:ext cx="2468880" cy="411480"/>
+            <a:ext cx="2468880" cy="292388"/>
           </a:xfrm>
           <a:prstGeom prst="rect">
             <a:avLst/>
@@ -4009,12 +4138,28 @@
           <a:p>
             <a:pPr algn="l"/>
             <a:r>
-              <a:rPr sz="1300" b="1" i="0">
+              <a:rPr sz="1300" b="1" i="0" dirty="0">
                 <a:solidFill>
                   <a:srgbClr val="FFFFFF"/>
                 </a:solidFill>
               </a:rPr>
-              <a:t>B.Tech Gen AI  |  2026</a:t>
+              <a:t>Gen AI  </a:t>
+            </a:r>
+            <a:r>
+              <a:rPr lang="en-IN" sz="1300" b="1" i="0" dirty="0">
+                <a:solidFill>
+                  <a:srgbClr val="FFFFFF"/>
+                </a:solidFill>
+              </a:rPr>
+              <a:t>- B | IBM </a:t>
+            </a:r>
+            <a:r>
+              <a:rPr sz="1300" b="1" i="0" dirty="0">
+                <a:solidFill>
+                  <a:srgbClr val="FFFFFF"/>
+                </a:solidFill>
+              </a:rPr>
+              <a:t>|  2026</a:t>
             </a:r>
           </a:p>
         </p:txBody>
@@ -4062,7 +4207,7 @@
 </file>
 
 <file path=ppt/slides/slide2.xml><?xml version="1.0" encoding="utf-8"?>
-<p:sld xmlns:a="http://schemas.openxmlformats.org/drawingml/2006/main" xmlns:p="http://schemas.openxmlformats.org/presentationml/2006/main" xmlns:r="http://schemas.openxmlformats.org/officeDocument/2006/relationships">
+<p:sld xmlns:a="http://schemas.openxmlformats.org/drawingml/2006/main" xmlns:r="http://schemas.openxmlformats.org/officeDocument/2006/relationships" xmlns:p="http://schemas.openxmlformats.org/presentationml/2006/main">
   <p:cSld>
     <p:bg>
       <p:bgPr>
@@ -4078,7 +4223,14 @@
         <p:cNvGrpSpPr/>
         <p:nvPr/>
       </p:nvGrpSpPr>
-      <p:grpSpPr/>
+      <p:grpSpPr>
+        <a:xfrm>
+          <a:off x="0" y="0"/>
+          <a:ext cx="0" cy="0"/>
+          <a:chOff x="0" y="0"/>
+          <a:chExt cx="0" cy="0"/>
+        </a:xfrm>
+      </p:grpSpPr>
       <p:sp>
         <p:nvSpPr>
           <p:cNvPr id="2" name="Rectangle 1"/>
@@ -4119,6 +4271,7 @@
           <a:lstStyle/>
           <a:p>
             <a:pPr algn="ctr"/>
+            <a:endParaRPr/>
           </a:p>
         </p:txBody>
       </p:sp>
@@ -4162,6 +4315,7 @@
           <a:lstStyle/>
           <a:p>
             <a:pPr algn="ctr"/>
+            <a:endParaRPr/>
           </a:p>
         </p:txBody>
       </p:sp>
@@ -4239,6 +4393,7 @@
           <a:lstStyle/>
           <a:p>
             <a:pPr algn="ctr"/>
+            <a:endParaRPr/>
           </a:p>
         </p:txBody>
       </p:sp>
@@ -4282,6 +4437,7 @@
           <a:lstStyle/>
           <a:p>
             <a:pPr algn="ctr"/>
+            <a:endParaRPr/>
           </a:p>
         </p:txBody>
       </p:sp>
@@ -4495,6 +4651,7 @@
           <a:lstStyle/>
           <a:p>
             <a:pPr algn="ctr"/>
+            <a:endParaRPr/>
           </a:p>
         </p:txBody>
       </p:sp>
@@ -4538,6 +4695,7 @@
           <a:lstStyle/>
           <a:p>
             <a:pPr algn="ctr"/>
+            <a:endParaRPr/>
           </a:p>
         </p:txBody>
       </p:sp>
@@ -4751,6 +4909,7 @@
           <a:lstStyle/>
           <a:p>
             <a:pPr algn="ctr"/>
+            <a:endParaRPr/>
           </a:p>
         </p:txBody>
       </p:sp>
@@ -4794,6 +4953,7 @@
           <a:lstStyle/>
           <a:p>
             <a:pPr algn="ctr"/>
+            <a:endParaRPr/>
           </a:p>
         </p:txBody>
       </p:sp>
@@ -5007,6 +5167,7 @@
           <a:lstStyle/>
           <a:p>
             <a:pPr algn="ctr"/>
+            <a:endParaRPr/>
           </a:p>
         </p:txBody>
       </p:sp>
@@ -5053,7 +5214,7 @@
 </file>
 
 <file path=ppt/slides/slide3.xml><?xml version="1.0" encoding="utf-8"?>
-<p:sld xmlns:a="http://schemas.openxmlformats.org/drawingml/2006/main" xmlns:p="http://schemas.openxmlformats.org/presentationml/2006/main" xmlns:r="http://schemas.openxmlformats.org/officeDocument/2006/relationships">
+<p:sld xmlns:a="http://schemas.openxmlformats.org/drawingml/2006/main" xmlns:r="http://schemas.openxmlformats.org/officeDocument/2006/relationships" xmlns:p="http://schemas.openxmlformats.org/presentationml/2006/main">
   <p:cSld>
     <p:bg>
       <p:bgPr>
@@ -5069,7 +5230,14 @@
         <p:cNvGrpSpPr/>
         <p:nvPr/>
       </p:nvGrpSpPr>
-      <p:grpSpPr/>
+      <p:grpSpPr>
+        <a:xfrm>
+          <a:off x="0" y="0"/>
+          <a:ext cx="0" cy="0"/>
+          <a:chOff x="0" y="0"/>
+          <a:chExt cx="0" cy="0"/>
+        </a:xfrm>
+      </p:grpSpPr>
       <p:sp>
         <p:nvSpPr>
           <p:cNvPr id="2" name="Rectangle 1"/>
@@ -5110,6 +5278,7 @@
           <a:lstStyle/>
           <a:p>
             <a:pPr algn="ctr"/>
+            <a:endParaRPr/>
           </a:p>
         </p:txBody>
       </p:sp>
@@ -5153,6 +5322,7 @@
           <a:lstStyle/>
           <a:p>
             <a:pPr algn="ctr"/>
+            <a:endParaRPr/>
           </a:p>
         </p:txBody>
       </p:sp>
@@ -5230,6 +5400,7 @@
           <a:lstStyle/>
           <a:p>
             <a:pPr algn="ctr"/>
+            <a:endParaRPr/>
           </a:p>
         </p:txBody>
       </p:sp>
@@ -5545,6 +5716,7 @@
           <a:lstStyle/>
           <a:p>
             <a:pPr algn="ctr"/>
+            <a:endParaRPr/>
           </a:p>
         </p:txBody>
       </p:sp>
@@ -5724,6 +5896,7 @@
           <a:lstStyle/>
           <a:p>
             <a:pPr algn="ctr"/>
+            <a:endParaRPr/>
           </a:p>
         </p:txBody>
       </p:sp>
@@ -5869,6 +6042,7 @@
           <a:lstStyle/>
           <a:p>
             <a:pPr algn="ctr"/>
+            <a:endParaRPr/>
           </a:p>
         </p:txBody>
       </p:sp>
@@ -5946,6 +6120,7 @@
           <a:lstStyle/>
           <a:p>
             <a:pPr algn="ctr"/>
+            <a:endParaRPr/>
           </a:p>
         </p:txBody>
       </p:sp>
@@ -6091,6 +6266,7 @@
           <a:lstStyle/>
           <a:p>
             <a:pPr algn="ctr"/>
+            <a:endParaRPr/>
           </a:p>
         </p:txBody>
       </p:sp>
@@ -6168,6 +6344,7 @@
           <a:lstStyle/>
           <a:p>
             <a:pPr algn="ctr"/>
+            <a:endParaRPr/>
           </a:p>
         </p:txBody>
       </p:sp>
@@ -6313,6 +6490,7 @@
           <a:lstStyle/>
           <a:p>
             <a:pPr algn="ctr"/>
+            <a:endParaRPr/>
           </a:p>
         </p:txBody>
       </p:sp>
@@ -6390,6 +6568,7 @@
           <a:lstStyle/>
           <a:p>
             <a:pPr algn="ctr"/>
+            <a:endParaRPr/>
           </a:p>
         </p:txBody>
       </p:sp>
@@ -6535,6 +6714,7 @@
           <a:lstStyle/>
           <a:p>
             <a:pPr algn="ctr"/>
+            <a:endParaRPr/>
           </a:p>
         </p:txBody>
       </p:sp>
@@ -6612,6 +6792,7 @@
           <a:lstStyle/>
           <a:p>
             <a:pPr algn="ctr"/>
+            <a:endParaRPr/>
           </a:p>
         </p:txBody>
       </p:sp>
@@ -6757,6 +6938,7 @@
           <a:lstStyle/>
           <a:p>
             <a:pPr algn="ctr"/>
+            <a:endParaRPr/>
           </a:p>
         </p:txBody>
       </p:sp>
@@ -6834,6 +7016,7 @@
           <a:lstStyle/>
           <a:p>
             <a:pPr algn="ctr"/>
+            <a:endParaRPr/>
           </a:p>
         </p:txBody>
       </p:sp>
@@ -6979,6 +7162,7 @@
           <a:lstStyle/>
           <a:p>
             <a:pPr algn="ctr"/>
+            <a:endParaRPr/>
           </a:p>
         </p:txBody>
       </p:sp>
@@ -7056,6 +7240,7 @@
           <a:lstStyle/>
           <a:p>
             <a:pPr algn="ctr"/>
+            <a:endParaRPr/>
           </a:p>
         </p:txBody>
       </p:sp>
@@ -7201,6 +7386,7 @@
           <a:lstStyle/>
           <a:p>
             <a:pPr algn="ctr"/>
+            <a:endParaRPr/>
           </a:p>
         </p:txBody>
       </p:sp>
@@ -7278,6 +7464,7 @@
           <a:lstStyle/>
           <a:p>
             <a:pPr algn="ctr"/>
+            <a:endParaRPr/>
           </a:p>
         </p:txBody>
       </p:sp>
@@ -7324,7 +7511,7 @@
 </file>
 
 <file path=ppt/slides/slide4.xml><?xml version="1.0" encoding="utf-8"?>
-<p:sld xmlns:a="http://schemas.openxmlformats.org/drawingml/2006/main" xmlns:p="http://schemas.openxmlformats.org/presentationml/2006/main" xmlns:r="http://schemas.openxmlformats.org/officeDocument/2006/relationships">
+<p:sld xmlns:a="http://schemas.openxmlformats.org/drawingml/2006/main" xmlns:r="http://schemas.openxmlformats.org/officeDocument/2006/relationships" xmlns:p="http://schemas.openxmlformats.org/presentationml/2006/main">
   <p:cSld>
     <p:bg>
       <p:bgPr>
@@ -7340,7 +7527,14 @@
         <p:cNvGrpSpPr/>
         <p:nvPr/>
       </p:nvGrpSpPr>
-      <p:grpSpPr/>
+      <p:grpSpPr>
+        <a:xfrm>
+          <a:off x="0" y="0"/>
+          <a:ext cx="0" cy="0"/>
+          <a:chOff x="0" y="0"/>
+          <a:chExt cx="0" cy="0"/>
+        </a:xfrm>
+      </p:grpSpPr>
       <p:sp>
         <p:nvSpPr>
           <p:cNvPr id="2" name="Rectangle 1"/>
@@ -7381,6 +7575,7 @@
           <a:lstStyle/>
           <a:p>
             <a:pPr algn="ctr"/>
+            <a:endParaRPr/>
           </a:p>
         </p:txBody>
       </p:sp>
@@ -7424,6 +7619,7 @@
           <a:lstStyle/>
           <a:p>
             <a:pPr algn="ctr"/>
+            <a:endParaRPr/>
           </a:p>
         </p:txBody>
       </p:sp>
@@ -7501,6 +7697,7 @@
           <a:lstStyle/>
           <a:p>
             <a:pPr algn="ctr"/>
+            <a:endParaRPr/>
           </a:p>
         </p:txBody>
       </p:sp>
@@ -7544,6 +7741,7 @@
           <a:lstStyle/>
           <a:p>
             <a:pPr algn="ctr"/>
+            <a:endParaRPr/>
           </a:p>
         </p:txBody>
       </p:sp>
@@ -7587,6 +7785,7 @@
           <a:lstStyle/>
           <a:p>
             <a:pPr algn="ctr"/>
+            <a:endParaRPr/>
           </a:p>
         </p:txBody>
       </p:sp>
@@ -7834,6 +8033,7 @@
           <a:lstStyle/>
           <a:p>
             <a:pPr algn="ctr"/>
+            <a:endParaRPr/>
           </a:p>
         </p:txBody>
       </p:sp>
@@ -7877,6 +8077,7 @@
           <a:lstStyle/>
           <a:p>
             <a:pPr algn="ctr"/>
+            <a:endParaRPr/>
           </a:p>
         </p:txBody>
       </p:sp>
@@ -7920,6 +8121,7 @@
           <a:lstStyle/>
           <a:p>
             <a:pPr algn="ctr"/>
+            <a:endParaRPr/>
           </a:p>
         </p:txBody>
       </p:sp>
@@ -8167,6 +8369,7 @@
           <a:lstStyle/>
           <a:p>
             <a:pPr algn="ctr"/>
+            <a:endParaRPr/>
           </a:p>
         </p:txBody>
       </p:sp>
@@ -8210,6 +8413,7 @@
           <a:lstStyle/>
           <a:p>
             <a:pPr algn="ctr"/>
+            <a:endParaRPr/>
           </a:p>
         </p:txBody>
       </p:sp>
@@ -8253,6 +8457,7 @@
           <a:lstStyle/>
           <a:p>
             <a:pPr algn="ctr"/>
+            <a:endParaRPr/>
           </a:p>
         </p:txBody>
       </p:sp>
@@ -8500,6 +8705,7 @@
           <a:lstStyle/>
           <a:p>
             <a:pPr algn="ctr"/>
+            <a:endParaRPr/>
           </a:p>
         </p:txBody>
       </p:sp>
@@ -8543,6 +8749,7 @@
           <a:lstStyle/>
           <a:p>
             <a:pPr algn="ctr"/>
+            <a:endParaRPr/>
           </a:p>
         </p:txBody>
       </p:sp>
@@ -8586,6 +8793,7 @@
           <a:lstStyle/>
           <a:p>
             <a:pPr algn="ctr"/>
+            <a:endParaRPr/>
           </a:p>
         </p:txBody>
       </p:sp>
@@ -8799,6 +9007,7 @@
           <a:lstStyle/>
           <a:p>
             <a:pPr algn="ctr"/>
+            <a:endParaRPr/>
           </a:p>
         </p:txBody>
       </p:sp>
@@ -8845,7 +9054,7 @@
 </file>
 
 <file path=ppt/slides/slide5.xml><?xml version="1.0" encoding="utf-8"?>
-<p:sld xmlns:a="http://schemas.openxmlformats.org/drawingml/2006/main" xmlns:p="http://schemas.openxmlformats.org/presentationml/2006/main" xmlns:r="http://schemas.openxmlformats.org/officeDocument/2006/relationships">
+<p:sld xmlns:a="http://schemas.openxmlformats.org/drawingml/2006/main" xmlns:r="http://schemas.openxmlformats.org/officeDocument/2006/relationships" xmlns:p="http://schemas.openxmlformats.org/presentationml/2006/main">
   <p:cSld>
     <p:bg>
       <p:bgPr>
@@ -8861,7 +9070,14 @@
         <p:cNvGrpSpPr/>
         <p:nvPr/>
       </p:nvGrpSpPr>
-      <p:grpSpPr/>
+      <p:grpSpPr>
+        <a:xfrm>
+          <a:off x="0" y="0"/>
+          <a:ext cx="0" cy="0"/>
+          <a:chOff x="0" y="0"/>
+          <a:chExt cx="0" cy="0"/>
+        </a:xfrm>
+      </p:grpSpPr>
       <p:sp>
         <p:nvSpPr>
           <p:cNvPr id="2" name="Rectangle 1"/>
@@ -8902,6 +9118,7 @@
           <a:lstStyle/>
           <a:p>
             <a:pPr algn="ctr"/>
+            <a:endParaRPr/>
           </a:p>
         </p:txBody>
       </p:sp>
@@ -8945,6 +9162,7 @@
           <a:lstStyle/>
           <a:p>
             <a:pPr algn="ctr"/>
+            <a:endParaRPr/>
           </a:p>
         </p:txBody>
       </p:sp>
@@ -9022,6 +9240,7 @@
           <a:lstStyle/>
           <a:p>
             <a:pPr algn="ctr"/>
+            <a:endParaRPr/>
           </a:p>
         </p:txBody>
       </p:sp>
@@ -9065,6 +9284,7 @@
           <a:lstStyle/>
           <a:p>
             <a:pPr algn="ctr"/>
+            <a:endParaRPr/>
           </a:p>
         </p:txBody>
       </p:sp>
@@ -9108,6 +9328,7 @@
           <a:lstStyle/>
           <a:p>
             <a:pPr algn="ctr"/>
+            <a:endParaRPr/>
           </a:p>
         </p:txBody>
       </p:sp>
@@ -9219,6 +9440,7 @@
           <a:lstStyle/>
           <a:p>
             <a:pPr algn="ctr"/>
+            <a:endParaRPr/>
           </a:p>
         </p:txBody>
       </p:sp>
@@ -9262,6 +9484,7 @@
           <a:lstStyle/>
           <a:p>
             <a:pPr algn="ctr"/>
+            <a:endParaRPr/>
           </a:p>
         </p:txBody>
       </p:sp>
@@ -9373,6 +9596,7 @@
           <a:lstStyle/>
           <a:p>
             <a:pPr algn="ctr"/>
+            <a:endParaRPr/>
           </a:p>
         </p:txBody>
       </p:sp>
@@ -9416,6 +9640,7 @@
           <a:lstStyle/>
           <a:p>
             <a:pPr algn="ctr"/>
+            <a:endParaRPr/>
           </a:p>
         </p:txBody>
       </p:sp>
@@ -9527,6 +9752,7 @@
           <a:lstStyle/>
           <a:p>
             <a:pPr algn="ctr"/>
+            <a:endParaRPr/>
           </a:p>
         </p:txBody>
       </p:sp>
@@ -9570,6 +9796,7 @@
           <a:lstStyle/>
           <a:p>
             <a:pPr algn="ctr"/>
+            <a:endParaRPr/>
           </a:p>
         </p:txBody>
       </p:sp>
@@ -9681,6 +9908,7 @@
           <a:lstStyle/>
           <a:p>
             <a:pPr algn="ctr"/>
+            <a:endParaRPr/>
           </a:p>
         </p:txBody>
       </p:sp>
@@ -9724,6 +9952,7 @@
           <a:lstStyle/>
           <a:p>
             <a:pPr algn="ctr"/>
+            <a:endParaRPr/>
           </a:p>
         </p:txBody>
       </p:sp>
@@ -9835,6 +10064,7 @@
           <a:lstStyle/>
           <a:p>
             <a:pPr algn="ctr"/>
+            <a:endParaRPr/>
           </a:p>
         </p:txBody>
       </p:sp>
@@ -10082,6 +10312,7 @@
           <a:lstStyle/>
           <a:p>
             <a:pPr algn="ctr"/>
+            <a:endParaRPr/>
           </a:p>
         </p:txBody>
       </p:sp>
@@ -10159,6 +10390,7 @@
           <a:lstStyle/>
           <a:p>
             <a:pPr algn="ctr"/>
+            <a:endParaRPr/>
           </a:p>
         </p:txBody>
       </p:sp>
@@ -10406,6 +10638,7 @@
           <a:lstStyle/>
           <a:p>
             <a:pPr algn="ctr"/>
+            <a:endParaRPr/>
           </a:p>
         </p:txBody>
       </p:sp>
@@ -10483,6 +10716,7 @@
           <a:lstStyle/>
           <a:p>
             <a:pPr algn="ctr"/>
+            <a:endParaRPr/>
           </a:p>
         </p:txBody>
       </p:sp>
@@ -10529,7 +10763,7 @@
 </file>
 
 <file path=ppt/slides/slide6.xml><?xml version="1.0" encoding="utf-8"?>
-<p:sld xmlns:a="http://schemas.openxmlformats.org/drawingml/2006/main" xmlns:p="http://schemas.openxmlformats.org/presentationml/2006/main" xmlns:r="http://schemas.openxmlformats.org/officeDocument/2006/relationships">
+<p:sld xmlns:a="http://schemas.openxmlformats.org/drawingml/2006/main" xmlns:r="http://schemas.openxmlformats.org/officeDocument/2006/relationships" xmlns:p="http://schemas.openxmlformats.org/presentationml/2006/main">
   <p:cSld>
     <p:bg>
       <p:bgPr>
@@ -10545,7 +10779,14 @@
         <p:cNvGrpSpPr/>
         <p:nvPr/>
       </p:nvGrpSpPr>
-      <p:grpSpPr/>
+      <p:grpSpPr>
+        <a:xfrm>
+          <a:off x="0" y="0"/>
+          <a:ext cx="0" cy="0"/>
+          <a:chOff x="0" y="0"/>
+          <a:chExt cx="0" cy="0"/>
+        </a:xfrm>
+      </p:grpSpPr>
       <p:sp>
         <p:nvSpPr>
           <p:cNvPr id="2" name="Rectangle 1"/>
@@ -10586,6 +10827,7 @@
           <a:lstStyle/>
           <a:p>
             <a:pPr algn="ctr"/>
+            <a:endParaRPr/>
           </a:p>
         </p:txBody>
       </p:sp>
@@ -10629,6 +10871,7 @@
           <a:lstStyle/>
           <a:p>
             <a:pPr algn="ctr"/>
+            <a:endParaRPr/>
           </a:p>
         </p:txBody>
       </p:sp>
@@ -10706,6 +10949,7 @@
           <a:lstStyle/>
           <a:p>
             <a:pPr algn="ctr"/>
+            <a:endParaRPr/>
           </a:p>
         </p:txBody>
       </p:sp>
@@ -10749,6 +10993,7 @@
           <a:lstStyle/>
           <a:p>
             <a:pPr algn="ctr"/>
+            <a:endParaRPr/>
           </a:p>
         </p:txBody>
       </p:sp>
@@ -10792,6 +11037,7 @@
           <a:lstStyle/>
           <a:p>
             <a:pPr algn="ctr"/>
+            <a:endParaRPr/>
           </a:p>
         </p:txBody>
       </p:sp>
@@ -10937,6 +11183,7 @@
           <a:lstStyle/>
           <a:p>
             <a:pPr algn="ctr"/>
+            <a:endParaRPr/>
           </a:p>
         </p:txBody>
       </p:sp>
@@ -10980,6 +11227,7 @@
           <a:lstStyle/>
           <a:p>
             <a:pPr algn="ctr"/>
+            <a:endParaRPr/>
           </a:p>
         </p:txBody>
       </p:sp>
@@ -11023,6 +11271,7 @@
           <a:lstStyle/>
           <a:p>
             <a:pPr algn="ctr"/>
+            <a:endParaRPr/>
           </a:p>
         </p:txBody>
       </p:sp>
@@ -11168,6 +11417,7 @@
           <a:lstStyle/>
           <a:p>
             <a:pPr algn="ctr"/>
+            <a:endParaRPr/>
           </a:p>
         </p:txBody>
       </p:sp>
@@ -11211,6 +11461,7 @@
           <a:lstStyle/>
           <a:p>
             <a:pPr algn="ctr"/>
+            <a:endParaRPr/>
           </a:p>
         </p:txBody>
       </p:sp>
@@ -11254,6 +11505,7 @@
           <a:lstStyle/>
           <a:p>
             <a:pPr algn="ctr"/>
+            <a:endParaRPr/>
           </a:p>
         </p:txBody>
       </p:sp>
@@ -11399,6 +11651,7 @@
           <a:lstStyle/>
           <a:p>
             <a:pPr algn="ctr"/>
+            <a:endParaRPr/>
           </a:p>
         </p:txBody>
       </p:sp>
@@ -11442,6 +11695,7 @@
           <a:lstStyle/>
           <a:p>
             <a:pPr algn="ctr"/>
+            <a:endParaRPr/>
           </a:p>
         </p:txBody>
       </p:sp>
@@ -11485,6 +11739,7 @@
           <a:lstStyle/>
           <a:p>
             <a:pPr algn="ctr"/>
+            <a:endParaRPr/>
           </a:p>
         </p:txBody>
       </p:sp>
@@ -11630,6 +11885,7 @@
           <a:lstStyle/>
           <a:p>
             <a:pPr algn="ctr"/>
+            <a:endParaRPr/>
           </a:p>
         </p:txBody>
       </p:sp>
@@ -11673,6 +11929,7 @@
           <a:lstStyle/>
           <a:p>
             <a:pPr algn="ctr"/>
+            <a:endParaRPr/>
           </a:p>
         </p:txBody>
       </p:sp>
@@ -11716,6 +11973,7 @@
           <a:lstStyle/>
           <a:p>
             <a:pPr algn="ctr"/>
+            <a:endParaRPr/>
           </a:p>
         </p:txBody>
       </p:sp>
@@ -11861,6 +12119,7 @@
           <a:lstStyle/>
           <a:p>
             <a:pPr algn="ctr"/>
+            <a:endParaRPr/>
           </a:p>
         </p:txBody>
       </p:sp>
@@ -11904,6 +12163,7 @@
           <a:lstStyle/>
           <a:p>
             <a:pPr algn="ctr"/>
+            <a:endParaRPr/>
           </a:p>
         </p:txBody>
       </p:sp>
@@ -11947,6 +12207,7 @@
           <a:lstStyle/>
           <a:p>
             <a:pPr algn="ctr"/>
+            <a:endParaRPr/>
           </a:p>
         </p:txBody>
       </p:sp>
@@ -12092,6 +12353,7 @@
           <a:lstStyle/>
           <a:p>
             <a:pPr algn="ctr"/>
+            <a:endParaRPr/>
           </a:p>
         </p:txBody>
       </p:sp>
@@ -12138,7 +12400,7 @@
 </file>
 
 <file path=ppt/slides/slide7.xml><?xml version="1.0" encoding="utf-8"?>
-<p:sld xmlns:a="http://schemas.openxmlformats.org/drawingml/2006/main" xmlns:p="http://schemas.openxmlformats.org/presentationml/2006/main" xmlns:r="http://schemas.openxmlformats.org/officeDocument/2006/relationships">
+<p:sld xmlns:a="http://schemas.openxmlformats.org/drawingml/2006/main" xmlns:r="http://schemas.openxmlformats.org/officeDocument/2006/relationships" xmlns:p="http://schemas.openxmlformats.org/presentationml/2006/main">
   <p:cSld>
     <p:bg>
       <p:bgPr>
@@ -12154,7 +12416,14 @@
         <p:cNvGrpSpPr/>
         <p:nvPr/>
       </p:nvGrpSpPr>
-      <p:grpSpPr/>
+      <p:grpSpPr>
+        <a:xfrm>
+          <a:off x="0" y="0"/>
+          <a:ext cx="0" cy="0"/>
+          <a:chOff x="0" y="0"/>
+          <a:chExt cx="0" cy="0"/>
+        </a:xfrm>
+      </p:grpSpPr>
       <p:sp>
         <p:nvSpPr>
           <p:cNvPr id="2" name="Rectangle 1"/>
@@ -12195,6 +12464,7 @@
           <a:lstStyle/>
           <a:p>
             <a:pPr algn="ctr"/>
+            <a:endParaRPr/>
           </a:p>
         </p:txBody>
       </p:sp>
@@ -12238,6 +12508,7 @@
           <a:lstStyle/>
           <a:p>
             <a:pPr algn="ctr"/>
+            <a:endParaRPr/>
           </a:p>
         </p:txBody>
       </p:sp>
@@ -12315,6 +12586,7 @@
           <a:lstStyle/>
           <a:p>
             <a:pPr algn="ctr"/>
+            <a:endParaRPr/>
           </a:p>
         </p:txBody>
       </p:sp>
@@ -12392,6 +12664,7 @@
           <a:lstStyle/>
           <a:p>
             <a:pPr algn="ctr"/>
+            <a:endParaRPr/>
           </a:p>
         </p:txBody>
       </p:sp>
@@ -12605,6 +12878,7 @@
           <a:lstStyle/>
           <a:p>
             <a:pPr algn="ctr"/>
+            <a:endParaRPr/>
           </a:p>
         </p:txBody>
       </p:sp>
@@ -12784,6 +13058,7 @@
           <a:lstStyle/>
           <a:p>
             <a:pPr algn="ctr"/>
+            <a:endParaRPr/>
           </a:p>
         </p:txBody>
       </p:sp>
@@ -12963,6 +13238,7 @@
           <a:lstStyle/>
           <a:p>
             <a:pPr algn="ctr"/>
+            <a:endParaRPr/>
           </a:p>
         </p:txBody>
       </p:sp>
@@ -13040,6 +13316,7 @@
           <a:lstStyle/>
           <a:p>
             <a:pPr algn="ctr"/>
+            <a:endParaRPr/>
           </a:p>
         </p:txBody>
       </p:sp>
@@ -13185,6 +13462,7 @@
           <a:lstStyle/>
           <a:p>
             <a:pPr algn="ctr"/>
+            <a:endParaRPr/>
           </a:p>
         </p:txBody>
       </p:sp>
@@ -13330,6 +13608,7 @@
           <a:lstStyle/>
           <a:p>
             <a:pPr algn="ctr"/>
+            <a:endParaRPr/>
           </a:p>
         </p:txBody>
       </p:sp>
@@ -13475,6 +13754,7 @@
           <a:lstStyle/>
           <a:p>
             <a:pPr algn="ctr"/>
+            <a:endParaRPr/>
           </a:p>
         </p:txBody>
       </p:sp>
@@ -13620,6 +13900,7 @@
           <a:lstStyle/>
           <a:p>
             <a:pPr algn="ctr"/>
+            <a:endParaRPr/>
           </a:p>
         </p:txBody>
       </p:sp>
@@ -13765,6 +14046,7 @@
           <a:lstStyle/>
           <a:p>
             <a:pPr algn="ctr"/>
+            <a:endParaRPr/>
           </a:p>
         </p:txBody>
       </p:sp>
@@ -13811,7 +14093,7 @@
 </file>
 
 <file path=ppt/slides/slide8.xml><?xml version="1.0" encoding="utf-8"?>
-<p:sld xmlns:a="http://schemas.openxmlformats.org/drawingml/2006/main" xmlns:p="http://schemas.openxmlformats.org/presentationml/2006/main" xmlns:r="http://schemas.openxmlformats.org/officeDocument/2006/relationships">
+<p:sld xmlns:a="http://schemas.openxmlformats.org/drawingml/2006/main" xmlns:r="http://schemas.openxmlformats.org/officeDocument/2006/relationships" xmlns:p="http://schemas.openxmlformats.org/presentationml/2006/main">
   <p:cSld>
     <p:bg>
       <p:bgPr>
@@ -13827,7 +14109,14 @@
         <p:cNvGrpSpPr/>
         <p:nvPr/>
       </p:nvGrpSpPr>
-      <p:grpSpPr/>
+      <p:grpSpPr>
+        <a:xfrm>
+          <a:off x="0" y="0"/>
+          <a:ext cx="0" cy="0"/>
+          <a:chOff x="0" y="0"/>
+          <a:chExt cx="0" cy="0"/>
+        </a:xfrm>
+      </p:grpSpPr>
       <p:sp>
         <p:nvSpPr>
           <p:cNvPr id="2" name="Rectangle 1"/>
@@ -13868,6 +14157,7 @@
           <a:lstStyle/>
           <a:p>
             <a:pPr algn="ctr"/>
+            <a:endParaRPr/>
           </a:p>
         </p:txBody>
       </p:sp>
@@ -13911,6 +14201,7 @@
           <a:lstStyle/>
           <a:p>
             <a:pPr algn="ctr"/>
+            <a:endParaRPr/>
           </a:p>
         </p:txBody>
       </p:sp>
@@ -13988,6 +14279,7 @@
           <a:lstStyle/>
           <a:p>
             <a:pPr algn="ctr"/>
+            <a:endParaRPr/>
           </a:p>
         </p:txBody>
       </p:sp>
@@ -14065,6 +14357,7 @@
           <a:lstStyle/>
           <a:p>
             <a:pPr algn="ctr"/>
+            <a:endParaRPr/>
           </a:p>
         </p:txBody>
       </p:sp>
@@ -14176,6 +14469,7 @@
           <a:lstStyle/>
           <a:p>
             <a:pPr algn="ctr"/>
+            <a:endParaRPr/>
           </a:p>
         </p:txBody>
       </p:sp>
@@ -14253,6 +14547,7 @@
           <a:lstStyle/>
           <a:p>
             <a:pPr algn="ctr"/>
+            <a:endParaRPr/>
           </a:p>
         </p:txBody>
       </p:sp>
@@ -14330,6 +14625,7 @@
           <a:lstStyle/>
           <a:p>
             <a:pPr algn="ctr"/>
+            <a:endParaRPr/>
           </a:p>
         </p:txBody>
       </p:sp>
@@ -14441,6 +14737,7 @@
           <a:lstStyle/>
           <a:p>
             <a:pPr algn="ctr"/>
+            <a:endParaRPr/>
           </a:p>
         </p:txBody>
       </p:sp>
@@ -14518,6 +14815,7 @@
           <a:lstStyle/>
           <a:p>
             <a:pPr algn="ctr"/>
+            <a:endParaRPr/>
           </a:p>
         </p:txBody>
       </p:sp>
@@ -14595,6 +14893,7 @@
           <a:lstStyle/>
           <a:p>
             <a:pPr algn="ctr"/>
+            <a:endParaRPr/>
           </a:p>
         </p:txBody>
       </p:sp>
@@ -14706,6 +15005,7 @@
           <a:lstStyle/>
           <a:p>
             <a:pPr algn="ctr"/>
+            <a:endParaRPr/>
           </a:p>
         </p:txBody>
       </p:sp>
@@ -14783,6 +15083,7 @@
           <a:lstStyle/>
           <a:p>
             <a:pPr algn="ctr"/>
+            <a:endParaRPr/>
           </a:p>
         </p:txBody>
       </p:sp>
@@ -14860,6 +15161,7 @@
           <a:lstStyle/>
           <a:p>
             <a:pPr algn="ctr"/>
+            <a:endParaRPr/>
           </a:p>
         </p:txBody>
       </p:sp>
@@ -14971,6 +15273,7 @@
           <a:lstStyle/>
           <a:p>
             <a:pPr algn="ctr"/>
+            <a:endParaRPr/>
           </a:p>
         </p:txBody>
       </p:sp>
@@ -15048,6 +15351,7 @@
           <a:lstStyle/>
           <a:p>
             <a:pPr algn="ctr"/>
+            <a:endParaRPr/>
           </a:p>
         </p:txBody>
       </p:sp>
@@ -15125,6 +15429,7 @@
           <a:lstStyle/>
           <a:p>
             <a:pPr algn="ctr"/>
+            <a:endParaRPr/>
           </a:p>
         </p:txBody>
       </p:sp>
@@ -15236,6 +15541,7 @@
           <a:lstStyle/>
           <a:p>
             <a:pPr algn="ctr"/>
+            <a:endParaRPr/>
           </a:p>
         </p:txBody>
       </p:sp>
@@ -15313,6 +15619,7 @@
           <a:lstStyle/>
           <a:p>
             <a:pPr algn="ctr"/>
+            <a:endParaRPr/>
           </a:p>
         </p:txBody>
       </p:sp>
@@ -15359,7 +15666,7 @@
 </file>
 
 <file path=ppt/slides/slide9.xml><?xml version="1.0" encoding="utf-8"?>
-<p:sld xmlns:a="http://schemas.openxmlformats.org/drawingml/2006/main" xmlns:p="http://schemas.openxmlformats.org/presentationml/2006/main" xmlns:r="http://schemas.openxmlformats.org/officeDocument/2006/relationships">
+<p:sld xmlns:a="http://schemas.openxmlformats.org/drawingml/2006/main" xmlns:r="http://schemas.openxmlformats.org/officeDocument/2006/relationships" xmlns:p="http://schemas.openxmlformats.org/presentationml/2006/main">
   <p:cSld>
     <p:bg>
       <p:bgPr>
@@ -15375,7 +15682,14 @@
         <p:cNvGrpSpPr/>
         <p:nvPr/>
       </p:nvGrpSpPr>
-      <p:grpSpPr/>
+      <p:grpSpPr>
+        <a:xfrm>
+          <a:off x="0" y="0"/>
+          <a:ext cx="0" cy="0"/>
+          <a:chOff x="0" y="0"/>
+          <a:chExt cx="0" cy="0"/>
+        </a:xfrm>
+      </p:grpSpPr>
       <p:sp>
         <p:nvSpPr>
           <p:cNvPr id="2" name="Rectangle 1"/>
@@ -15416,6 +15730,7 @@
           <a:lstStyle/>
           <a:p>
             <a:pPr algn="ctr"/>
+            <a:endParaRPr/>
           </a:p>
         </p:txBody>
       </p:sp>
@@ -15459,6 +15774,7 @@
           <a:lstStyle/>
           <a:p>
             <a:pPr algn="ctr"/>
+            <a:endParaRPr/>
           </a:p>
         </p:txBody>
       </p:sp>
@@ -15536,6 +15852,7 @@
           <a:lstStyle/>
           <a:p>
             <a:pPr algn="ctr"/>
+            <a:endParaRPr/>
           </a:p>
         </p:txBody>
       </p:sp>
@@ -15579,6 +15896,7 @@
           <a:lstStyle/>
           <a:p>
             <a:pPr algn="ctr"/>
+            <a:endParaRPr/>
           </a:p>
         </p:txBody>
       </p:sp>
@@ -15792,6 +16110,7 @@
           <a:lstStyle/>
           <a:p>
             <a:pPr algn="ctr"/>
+            <a:endParaRPr/>
           </a:p>
         </p:txBody>
       </p:sp>
@@ -15835,6 +16154,7 @@
           <a:lstStyle/>
           <a:p>
             <a:pPr algn="ctr"/>
+            <a:endParaRPr/>
           </a:p>
         </p:txBody>
       </p:sp>
@@ -16048,6 +16368,7 @@
           <a:lstStyle/>
           <a:p>
             <a:pPr algn="ctr"/>
+            <a:endParaRPr/>
           </a:p>
         </p:txBody>
       </p:sp>
@@ -16091,6 +16412,7 @@
           <a:lstStyle/>
           <a:p>
             <a:pPr algn="ctr"/>
+            <a:endParaRPr/>
           </a:p>
         </p:txBody>
       </p:sp>
@@ -16304,6 +16626,7 @@
           <a:lstStyle/>
           <a:p>
             <a:pPr algn="ctr"/>
+            <a:endParaRPr/>
           </a:p>
         </p:txBody>
       </p:sp>
@@ -16347,6 +16670,7 @@
           <a:lstStyle/>
           <a:p>
             <a:pPr algn="ctr"/>
+            <a:endParaRPr/>
           </a:p>
         </p:txBody>
       </p:sp>
@@ -16560,6 +16884,7 @@
           <a:lstStyle/>
           <a:p>
             <a:pPr algn="ctr"/>
+            <a:endParaRPr/>
           </a:p>
         </p:txBody>
       </p:sp>

</xml_diff>